<commit_message>
Deepen Weeks 4-6 (web unit) into full lectures + speaker notes
The W4-6 decks were already content-rich (worked examples, real-world cases, CWE maps,
RBAC exercise, log-reading, Burp workflow); this adds per-slide speaker notes following
the W1-3 template — delivery script, timing, questions to ask, common misconceptions,
and links to that week's game/quiz/project tasks.

Rebuilt week04-06.pptx (18/16/19 speaker-note parts; notes don't render on slides).
QA: worked-example slides clean on the white theme, no overflow.

First-half teaching weeks (W1-6) are now lecture-ready.

Co-Authored-By: Claude Opus 4.8 <noreply@anthropic.com>
</commit_message>
<xml_diff>
--- a/slides/pptx/week04.pptx
+++ b/slides/pptx/week04.pptx
@@ -519,7 +519,7 @@
           <a:p>
             <a:r>
               <a:rPr lang="en-US" dirty="0"/>
-              <a:t/>
+              <a:t>Hook: type one quote mark into a login box and become admin — promise that demo. Injection is the oldest trick that still works. Today they exploit it, then fix it for real. ~2 min.</a:t>
             </a:r>
             <a:endParaRPr lang="en-US" dirty="0"/>
           </a:p>
@@ -607,7 +607,7 @@
           <a:p>
             <a:r>
               <a:rPr lang="en-US" dirty="0"/>
-              <a:t/>
+              <a:t>Same pattern, deadlier outcome (RCE = own the server, not just the DB). Walk the metacharacters: `;` chains a second command. Ask: "what does `8.8.8.8; cat /etc/passwd` run?" ~5 min.</a:t>
             </a:r>
             <a:endParaRPr lang="en-US" dirty="0"/>
           </a:p>
@@ -695,7 +695,7 @@
           <a:p>
             <a:r>
               <a:rPr lang="en-US" dirty="0"/>
-              <a:t/>
+              <a:t>Connects to W1's /upload threat model — now it's a full exploit chain. The webshell is tiny and total. This reappears in the W6 log-reading slide. Stress the layered fix (type + extension + location + no-exec). ~5 min.</a:t>
             </a:r>
             <a:endParaRPr lang="en-US" dirty="0"/>
           </a:p>
@@ -783,7 +783,7 @@
           <a:p>
             <a:r>
               <a:rPr lang="en-US" dirty="0"/>
-              <a:t/>
+              <a:t>They map every lab finding to a CWE id. Quick slide — these are the ids to cite in the worksheet. ~1 min.</a:t>
             </a:r>
             <a:endParaRPr lang="en-US" dirty="0"/>
           </a:p>
@@ -871,7 +871,7 @@
           <a:p>
             <a:r>
               <a:rPr lang="en-US" dirty="0"/>
-              <a:t/>
+              <a:t>The payoff. #1 message: parameterization makes data STAY data — the DB never parses it as SQL. For shells, pass an argv array, not a string. Least-privilege limits blast radius if they still get in. ~5 min.</a:t>
             </a:r>
             <a:endParaRPr lang="en-US" dirty="0"/>
           </a:p>
@@ -959,7 +959,7 @@
           <a:p>
             <a:r>
               <a:rPr lang="en-US" dirty="0"/>
-              <a:t/>
+              <a:t>Explain before lab: levels escalate (raw → quoted → filtered → boss). Round 2 (patch it) is where the real learning is — and the deliverable. Leaderboard on capture time. Flags are per-student. ~3 min.</a:t>
             </a:r>
             <a:endParaRPr lang="en-US" dirty="0"/>
           </a:p>
@@ -1047,7 +1047,7 @@
           <a:p>
             <a:r>
               <a:rPr lang="en-US" dirty="0"/>
-              <a:t/>
+              <a:t>Logistics. Circulate with TAs. Remind: step 4 (rewrite + prove the payload now fails) is graded, not just the exploit. Also kick off the NoteVault project injection task (worksheet).</a:t>
             </a:r>
             <a:endParaRPr lang="en-US" dirty="0"/>
           </a:p>
@@ -1135,7 +1135,7 @@
           <a:p>
             <a:r>
               <a:rPr lang="en-US" dirty="0"/>
-              <a:t/>
+              <a:t>Set expectations: before AND after code + proof. The AI-resilient tasks are part of the grade. Q6 of this week's quiz asks for their own payload + personal flag.</a:t>
             </a:r>
             <a:endParaRPr lang="en-US" dirty="0"/>
           </a:p>
@@ -1223,7 +1223,7 @@
           <a:p>
             <a:r>
               <a:rPr lang="en-US" dirty="0"/>
-              <a:t/>
+              <a:t>Recap in 3 lines. Cold-call: "what's the ONE fix for SQLi?" (parameterized queries). ~2 min.</a:t>
             </a:r>
             <a:endParaRPr lang="en-US" dirty="0"/>
           </a:p>
@@ -1311,7 +1311,7 @@
           <a:p>
             <a:r>
               <a:rPr lang="en-US" dirty="0"/>
-              <a:t/>
+              <a:t>Cliffhanger: "Next week the same trick runs in the victim's browser — and skims credit cards." Remind DVWA/Juice Shop ready in their VM.</a:t>
             </a:r>
             <a:endParaRPr lang="en-US" dirty="0"/>
           </a:p>
@@ -1399,7 +1399,7 @@
           <a:p>
             <a:r>
               <a:rPr lang="en-US" dirty="0"/>
-              <a:t/>
+              <a:t>Roadmap, 1 min. Tell them the one big idea (data becomes code) unifies SQLi, command injection, and even XSS next week. Lab = exploit DVWA/Juice Shop then patch it.</a:t>
             </a:r>
             <a:endParaRPr lang="en-US" dirty="0"/>
           </a:p>
@@ -1487,7 +1487,7 @@
           <a:p>
             <a:r>
               <a:rPr lang="en-US" dirty="0"/>
-              <a:t/>
+              <a:t>1-min bridge. Last week we protected data at rest; today the attacker sends malicious data IN. Cold-call: "how should we store passwords?" to check W3 stuck.</a:t>
             </a:r>
             <a:endParaRPr lang="en-US" dirty="0"/>
           </a:p>
@@ -1575,7 +1575,7 @@
           <a:p>
             <a:r>
               <a:rPr lang="en-US" dirty="0"/>
-              <a:t/>
+              <a:t>This is THE mental model for the whole week — say it twice. Every injection is the same shape: an interpreter can't tell your data from its own instructions. Ask the class to name interpreters in a typical app (DB, shell, template). ~5 min.</a:t>
             </a:r>
             <a:endParaRPr lang="en-US" dirty="0"/>
           </a:p>
@@ -1663,7 +1663,7 @@
           <a:p>
             <a:r>
               <a:rPr lang="en-US" dirty="0"/>
-              <a:t/>
+              <a:t>Walk the string-concatenation on the board: show how the quote in the input lands inside the SQL string and breaks out. Distinguish UNION (read other tables in one shot) vs blind (no output → infer via true/false or timing). ~7 min.</a:t>
             </a:r>
             <a:endParaRPr lang="en-US" dirty="0"/>
           </a:p>
@@ -1751,7 +1751,7 @@
           <a:p>
             <a:r>
               <a:rPr lang="en-US" dirty="0"/>
-              <a:t/>
+              <a:t>The worked example — slow down here. Decompose the payload token by token; this is exactly the SQLi Boss Fight round 1. Stress the space after `--` (MySQL needs it) — the #1 reason a student's payload "doesn't work". ~8 min.</a:t>
             </a:r>
             <a:endParaRPr lang="en-US" dirty="0"/>
           </a:p>
@@ -1839,7 +1839,7 @@
           <a:p>
             <a:r>
               <a:rPr lang="en-US" dirty="0"/>
-              <a:t/>
+              <a:t>Make it real — these are careers ended and companies fined. Equifax = a single unpatched input parser. Tie back: every breach here started as "untrusted data interpreted as code". ~4 min.</a:t>
             </a:r>
             <a:endParaRPr lang="en-US" dirty="0"/>
           </a:p>
@@ -1927,7 +1927,7 @@
           <a:p>
             <a:r>
               <a:rPr lang="en-US" dirty="0"/>
-              <a:t/>
+              <a:t>Key principle that recurs all term. Block-lists always lose (attackers invent new payloads); allow-lists define what's acceptable. Emphasize: validation is defense-in-depth, NOT the primary SQLi fix (that's parameterization — next). ~4 min.</a:t>
             </a:r>
             <a:endParaRPr lang="en-US" dirty="0"/>
           </a:p>
@@ -2015,7 +2015,7 @@
           <a:p>
             <a:r>
               <a:rPr lang="en-US" dirty="0"/>
-              <a:t/>
+              <a:t>Point out injection isn't just login boxes — any input reaching an interpreter. Note verbose DB errors are a gift to attackers (schema leakage). Reiterate ethics: sqlmap only on provided sandbox targets. ~3 min.</a:t>
             </a:r>
             <a:endParaRPr lang="en-US" dirty="0"/>
           </a:p>
@@ -5250,11 +5250,11 @@
         <p:spPr>
           <a:xfrm>
             <a:off x="457200" y="1325880"/>
-            <a:ext cx="8229600" cy="1207008"/>
+            <a:ext cx="8229600" cy="1517904"/>
           </a:xfrm>
           <a:prstGeom prst="roundRect">
             <a:avLst>
-              <a:gd name="adj" fmla="val 6061"/>
+              <a:gd name="adj" fmla="val 4819"/>
             </a:avLst>
           </a:prstGeom>
           <a:solidFill>
@@ -5279,7 +5279,7 @@
         <p:spPr>
           <a:xfrm>
             <a:off x="731520" y="1435608"/>
-            <a:ext cx="7680960" cy="987552"/>
+            <a:ext cx="7680960" cy="1298448"/>
           </a:xfrm>
           <a:prstGeom prst="rect">
             <a:avLst/>
@@ -5350,6 +5350,27 @@
                 <a:cs typeface="Calibri" pitchFamily="34" charset="-120"/>
               </a:rPr>
               <a:t>Proof the payload no longer works</a:t>
+            </a:r>
+            <a:endParaRPr lang="en-US" sz="1400" dirty="0"/>
+          </a:p>
+          <a:p>
+            <a:pPr marL="342900" indent="-342900">
+              <a:spcAft>
+                <a:spcPts val="600"/>
+              </a:spcAft>
+              <a:buSzPct val="100000"/>
+              <a:buChar char="•"/>
+            </a:pPr>
+            <a:r>
+              <a:rPr lang="en-US" sz="1400" dirty="0">
+                <a:solidFill>
+                  <a:srgbClr val="1F2937"/>
+                </a:solidFill>
+                <a:latin typeface="Calibri" pitchFamily="34" charset="0"/>
+                <a:ea typeface="Calibri" pitchFamily="34" charset="-122"/>
+                <a:cs typeface="Calibri" pitchFamily="34" charset="-120"/>
+              </a:rPr>
+              <a:t>+ Audit the AI / EiPE / Prompt Problem (see worksheet)</a:t>
             </a:r>
             <a:endParaRPr lang="en-US" sz="1400" dirty="0"/>
           </a:p>

</xml_diff>